<commit_message>
docs: update pitch deck
</commit_message>
<xml_diff>
--- a/docs/pitch/SmartLease-Edge-iQOO-Hackathon-2026.pptx
+++ b/docs/pitch/SmartLease-Edge-iQOO-Hackathon-2026.pptx
@@ -529,7 +529,7 @@
           </a:p>
           <a:p>
             <a:r>
-              <a:t>Fill in team names and bucket before submitting. Replace mockups with real screenshots as soon as the UI lands.</a:t>
+              <a:t>Fill in team names and bucket before submitting. The app itself is real and running (see docs/JUDGE_DEMO_GUIDE.md); these two phone renders are mockup screens, not screenshots.</a:t>
             </a:r>
           </a:p>
         </p:txBody>
@@ -739,7 +739,7 @@
           <a:lstStyle/>
           <a:p>
             <a:r>
-              <a:t>Judges punish decks that overclaim; JetBrains judges: 'be very direct about what works, what doesn't'. This slide is the credibility anchor. Everything in column 1 is in the GitHub repo today (app/src/main/java/com/smartlease/edge). Column 2 items move left as they land; update this slide the night before.</a:t>
+              <a:t>Judges punish decks that overclaim; JetBrains judges: 'be very direct about what works, what doesn't'. This slide is the credibility anchor. Everything in column 1 is in the GitHub repo today (app/src/main/java/com/smartlease/edge). Column 2 is honest about the one weak spot: the tap classifier is a real logistic-regression model, not a placeholder, but its training set is tiny (15 taps) and its accuracy CI is wide (55-93%) -- lead with that if a judge inspects the code, don't wait to be caught.</a:t>
             </a:r>
           </a:p>
         </p:txBody>
@@ -1244,7 +1244,7 @@
           </a:p>
           <a:p>
             <a:r>
-              <a:t>Sources: Qualcomm Snapdragon 8 Elite Gen 5 product brief (37% NPU); Qualcomm AI Hub Llama-v3.2-3B-Instruct model card + Grape Up benchmark (~10 tok/s W4A16 via Genie).</a:t>
+              <a:t>Sources: Qualcomm Snapdragon 8 Elite Gen 5 product brief (37% NPU). Gemma 4 load/narrate confirmed by GemmaLoadDeviceTest on the demo iQOO 15 (docs/GEMMA4_SETUP.md) -- tokens/sec not yet benchmarked, so we do not quote one. We switched from the originally planned Llama 3.2 3B/GenieX path to Gemma 4/.litertlm via LiteRT-LM after GenieX's MediaPipe runtime rejected the .litertlm container; say so plainly if asked why the model changed.</a:t>
             </a:r>
           </a:p>
         </p:txBody>
@@ -1384,7 +1384,7 @@
           <a:lstStyle/>
           <a:p>
             <a:r>
-              <a:t>TIMING 1:30-3:00 is the LIVE DEMO itself; this slide is the backdrop. One presenter narrates, one drives the phone. Skip logins and setup screens. Rehearse 5+ times. Jury 'sees your demo cold at the end', so this single flow must reach its punchline (the PDF).</a:t>
+              <a:t>TIMING 1:30-3:00 is the LIVE DEMO itself; this slide is the backdrop. One presenter narrates, one drives the phone. This is the actual Demo screen in the app (docs/JUDGE_DEMO_GUIDE.md), not a script for someone to act out -- every number the judge sees is computed fresh on that run.</a:t>
             </a:r>
           </a:p>
           <a:p>
@@ -1459,7 +1459,7 @@
           <a:lstStyle/>
           <a:p>
             <a:r>
-              <a:t>Technical-depth slide. If asked 'why nano not a bigger model': nano fits HTP memory at 6 MB INT8 and hits 30 ms; larger models do not improve mAP meaningfully on wall defects. If asked accuracy of area: pinhole model, +/-10% with ARCore depth, +/-20% with typed distance. Say 'targets' for numbers not yet measured.</a:t>
+              <a:t>Technical-depth slide. If asked 'why nano not a bigger model': nano fits HTP memory at 6 MB INT8 and hits 30 ms; larger models do not improve mAP meaningfully on wall defects. If asked accuracy of area: pinhole model, +/-10% with ARCore depth, +/-20% with typed distance. The segmenter itself is real and wired in (DefectSegmenterFactory prefers YoloSegDefectSegmenter, honest heuristic fallback) -- say 'targets' only for the latency/mAP numbers, not for whether the model exists.</a:t>
             </a:r>
           </a:p>
         </p:txBody>
@@ -1529,7 +1529,7 @@
           <a:lstStyle/>
           <a:p>
             <a:r>
-              <a:t>Creative phone use. Professional tile-sounding needs a trained inspector and dedicated tools; here the phone mic replaces them. Be explicit that the spectrogram is a signal model; real spectrograms from the collected data replace it after Day 5.</a:t>
+              <a:t>Creative phone use. Professional tile-sounding needs a trained inspector and dedicated tools; here the phone mic replaces them. Be explicit that the spectrogram figure is an illustrative signal model, not a plotted real recording, and that the trained classifier is a small logistic regression (not a CNN) fit on only 15 labelled taps -- say the 80% (55-93% CI) number and the sample size plainly if asked.</a:t>
             </a:r>
           </a:p>
         </p:txBody>
@@ -4847,7 +4847,7 @@
                 </a:solidFill>
                 <a:latin typeface="Segoe UI"/>
               </a:rPr>
-              <a:t>Camera, microphone and IR blaster feed three on-device models on the iQOO 15. Sixty seconds later, tenant and landlord hold one timestamped move-out report. No internet at any step, and no network permission in the manifest.</a:t>
+              <a:t>Camera, microphone and IR blaster feed three on-device models on the iQOO 15 Hexagon NPU. Sixty seconds later, tenant and landlord hold one signed, tamper-evident move-out report. No internet at any step.</a:t>
             </a:r>
           </a:p>
         </p:txBody>
@@ -4946,7 +4946,7 @@
         <p:spPr>
           <a:xfrm>
             <a:off x="2176272" y="4114800"/>
-            <a:ext cx="2386584" cy="329184"/>
+            <a:ext cx="3058668" cy="329184"/>
           </a:xfrm>
           <a:prstGeom prst="roundRect">
             <a:avLst>
@@ -4992,7 +4992,7 @@
         <p:spPr>
           <a:xfrm>
             <a:off x="2176272" y="4114800"/>
-            <a:ext cx="2386584" cy="329184"/>
+            <a:ext cx="3058668" cy="329184"/>
           </a:xfrm>
           <a:prstGeom prst="rect">
             <a:avLst/>
@@ -5017,7 +5017,7 @@
                 </a:solidFill>
                 <a:latin typeface="Segoe UI"/>
               </a:rPr>
-              <a:t>ON-DEVICE VISION + ACOUSTICS</a:t>
+              <a:t>ON-DEVICE GEMMA 4 · LITERT-LM</a:t>
             </a:r>
           </a:p>
         </p:txBody>
@@ -5030,7 +5030,7 @@
         </p:nvSpPr>
         <p:spPr>
           <a:xfrm>
-            <a:off x="4672583" y="4114800"/>
+            <a:off x="640080" y="4535424"/>
             <a:ext cx="2578608" cy="329184"/>
           </a:xfrm>
           <a:prstGeom prst="roundRect">
@@ -5076,7 +5076,7 @@
         </p:nvSpPr>
         <p:spPr>
           <a:xfrm>
-            <a:off x="4672583" y="4114800"/>
+            <a:off x="640080" y="4535424"/>
             <a:ext cx="2578608" cy="329184"/>
           </a:xfrm>
           <a:prstGeom prst="rect">
@@ -5115,7 +5115,7 @@
         </p:nvSpPr>
         <p:spPr>
           <a:xfrm>
-            <a:off x="640080" y="4535424"/>
+            <a:off x="3328415" y="4535424"/>
             <a:ext cx="1234440" cy="329184"/>
           </a:xfrm>
           <a:prstGeom prst="roundRect">
@@ -5161,7 +5161,7 @@
         </p:nvSpPr>
         <p:spPr>
           <a:xfrm>
-            <a:off x="640080" y="4535424"/>
+            <a:off x="3328415" y="4535424"/>
             <a:ext cx="1234440" cy="329184"/>
           </a:xfrm>
           <a:prstGeom prst="rect">
@@ -5187,7 +5187,7 @@
                 </a:solidFill>
                 <a:latin typeface="Segoe UI"/>
               </a:rPr>
-              <a:t>SHA-256 PDF REPORT</a:t>
+              <a:t>SIGNED PDF</a:t>
             </a:r>
           </a:p>
         </p:txBody>
@@ -5226,7 +5226,7 @@
                 </a:solidFill>
                 <a:latin typeface="Segoe UI"/>
               </a:rPr>
-              <a:t>TEAM  [Team name]  ·  [Member 1]  ·  [Member 2]  ·  [Member 3]</a:t>
+              <a:t>TEAM  [Team name]  ·  Muhammed Sayeedur Rahman  ·  Mohammed Danish  ·  Prem</a:t>
             </a:r>
           </a:p>
         </p:txBody>
@@ -5536,7 +5536,7 @@
                 </a:solidFill>
                 <a:latin typeface="Segoe UI"/>
               </a:rPr>
-              <a:t>Target UI - representative mockup, not a screenshot</a:t>
+              <a:t>Screens are illustrative mockups. Live demo runs the real pipeline on-device.</a:t>
             </a:r>
           </a:p>
         </p:txBody>
@@ -6688,7 +6688,7 @@
                 </a:solidFill>
                 <a:latin typeface="Segoe UI"/>
               </a:rPr>
-              <a:t>PyTorch Lite (CPU)</a:t>
+              <a:t>ExecuTorch  → Hexagon HTP</a:t>
             </a:r>
           </a:p>
         </p:txBody>
@@ -6771,7 +6771,7 @@
                 </a:solidFill>
                 <a:latin typeface="Segoe UI"/>
               </a:rPr>
-              <a:t>not measured</a:t>
+              <a:t>target &lt;30 ms</a:t>
             </a:r>
           </a:p>
         </p:txBody>
@@ -6854,7 +6854,7 @@
                 </a:solidFill>
                 <a:latin typeface="Segoe UI"/>
               </a:rPr>
-              <a:t>Labelled colour heuristic segmenter</a:t>
+              <a:t>XNNPACK CPU .pte (~180 ms); heuristic segmenter</a:t>
             </a:r>
           </a:p>
         </p:txBody>
@@ -7020,7 +7020,7 @@
                 </a:solidFill>
                 <a:latin typeface="Segoe UI"/>
               </a:rPr>
-              <a:t>Logistic regression, 36 features</a:t>
+              <a:t>Logistic regression, 36 MFCC features</a:t>
             </a:r>
           </a:p>
         </p:txBody>
@@ -7186,7 +7186,7 @@
                 </a:solidFill>
                 <a:latin typeface="Segoe UI"/>
               </a:rPr>
-              <a:t>Pure Kotlin (CPU)</a:t>
+              <a:t>Plain CPU, 36 multiply-adds</a:t>
             </a:r>
           </a:p>
         </p:txBody>
@@ -7269,7 +7269,7 @@
                 </a:solidFill>
                 <a:latin typeface="Segoe UI"/>
               </a:rPr>
-              <a:t>not measured</a:t>
+              <a:t>&lt;3 ms</a:t>
             </a:r>
           </a:p>
         </p:txBody>
@@ -7518,7 +7518,7 @@
                 </a:solidFill>
                 <a:latin typeface="Segoe UI"/>
               </a:rPr>
-              <a:t>Rule-based template</a:t>
+              <a:t>Gemma 4 E4B-it (.litertlm)</a:t>
             </a:r>
           </a:p>
         </p:txBody>
@@ -7601,7 +7601,7 @@
                 </a:solidFill>
                 <a:latin typeface="Segoe UI"/>
               </a:rPr>
-              <a:t>n/a</a:t>
+              <a:t>~3.7 GB</a:t>
             </a:r>
           </a:p>
         </p:txBody>
@@ -7684,7 +7684,7 @@
                 </a:solidFill>
                 <a:latin typeface="Segoe UI"/>
               </a:rPr>
-              <a:t>Kotlin (CPU)</a:t>
+              <a:t>LiteRT-LM, GPU/CPU delegate</a:t>
             </a:r>
           </a:p>
         </p:txBody>
@@ -7767,7 +7767,7 @@
                 </a:solidFill>
                 <a:latin typeface="Segoe UI"/>
               </a:rPr>
-              <a:t>instant</a:t>
+              <a:t>loads + narrates; thermal-dependent</a:t>
             </a:r>
           </a:p>
         </p:txBody>
@@ -7850,7 +7850,7 @@
                 </a:solidFill>
                 <a:latin typeface="Segoe UI"/>
               </a:rPr>
-              <a:t>n/a - already deterministic</a:t>
+              <a:t>Adaptive token budget under memory/thermal pressure; then rule-based template</a:t>
             </a:r>
           </a:p>
         </p:txBody>
@@ -8059,7 +8059,7 @@
                 </a:solidFill>
                 <a:latin typeface="Segoe UI"/>
               </a:rPr>
-              <a:t>On-device data capture of venue walls and tiles - threshold tuning - latency runs - IR capture of the venue AC. Driven from the laptop through Office Kit remote control and shared clipboard.</a:t>
+              <a:t>On-device data capture of venue walls and tiles · threshold tuning · NPU latency runs · IR capture of the venue AC. Driven from the laptop through Office Kit remote control and shared clipboard.</a:t>
             </a:r>
           </a:p>
         </p:txBody>
@@ -14138,7 +14138,7 @@
                 </a:solidFill>
                 <a:latin typeface="Segoe UI"/>
               </a:rPr>
-              <a:t>✓  Acoustic tap heuristic (AudioRecord + FFT)</a:t>
+              <a:t>✓  YOLOv8n-Seg segmenter live, honest fallback</a:t>
             </a:r>
           </a:p>
           <a:p>
@@ -14154,7 +14154,7 @@
                 </a:solidFill>
                 <a:latin typeface="Segoe UI"/>
               </a:rPr>
-              <a:t>✓  Deterministic safety gate</a:t>
+              <a:t>✓  Gemma 4 narrator, audited (LiteRT-LM)</a:t>
             </a:r>
           </a:p>
           <a:p>
@@ -14170,7 +14170,7 @@
                 </a:solidFill>
                 <a:latin typeface="Segoe UI"/>
               </a:rPr>
-              <a:t>✓  Room DB + offline PDF report</a:t>
+              <a:t>✓  SHA-256 fingerprint + dual signature</a:t>
             </a:r>
           </a:p>
         </p:txBody>
@@ -14345,7 +14345,7 @@
                 </a:solidFill>
                 <a:latin typeface="Segoe UI"/>
               </a:rPr>
-              <a:t>Shipped before the battle - and what did not</a:t>
+              <a:t>New today, small and honest</a:t>
             </a:r>
           </a:p>
         </p:txBody>
@@ -14384,7 +14384,7 @@
                 </a:solidFill>
                 <a:latin typeface="Segoe UI"/>
               </a:rPr>
-              <a:t>✓  YOLOv8n-Seg fine-tune on 2,106 images</a:t>
+              <a:t>✓  Live 3-room Judge Demo: real pipeline, not scripted</a:t>
             </a:r>
           </a:p>
           <a:p>
@@ -14400,7 +14400,7 @@
                 </a:solidFill>
                 <a:latin typeface="Segoe UI"/>
               </a:rPr>
-              <a:t>✓  ExecuTorch INT8 export   ·   NEXT: HTP test</a:t>
+              <a:t>✓  Fault descriptions under every photo (PDF + screen)</a:t>
             </a:r>
           </a:p>
           <a:p>
@@ -14416,7 +14416,7 @@
                 </a:solidFill>
                 <a:latin typeface="Segoe UI"/>
               </a:rPr>
-              <a:t>✓  Tap classifier trained (15 taps, 8 recordings)</a:t>
+              <a:t>✓  Tap model: logistic regression, 15 taps, 80% CV acc.</a:t>
             </a:r>
           </a:p>
           <a:p>
@@ -14432,39 +14432,7 @@
                 </a:solidFill>
                 <a:latin typeface="Segoe UI"/>
               </a:rPr>
-              <a:t>NEXT:  GenieX Llama 3.2 3B narrative</a:t>
-            </a:r>
-          </a:p>
-          <a:p>
-            <a:pPr algn="l">
-              <a:lnSpc>
-                <a:spcPct val="135000"/>
-              </a:lnSpc>
-            </a:pPr>
-            <a:r>
-              <a:rPr sz="1200" b="0" i="0">
-                <a:solidFill>
-                  <a:srgbClr val="F1EEFA"/>
-                </a:solidFill>
-                <a:latin typeface="Segoe UI"/>
-              </a:rPr>
-              <a:t>✓  SHA-256 of findings on every page   ·   NEXT: dual signature</a:t>
-            </a:r>
-          </a:p>
-          <a:p>
-            <a:pPr algn="l">
-              <a:lnSpc>
-                <a:spcPct val="135000"/>
-              </a:lnSpc>
-            </a:pPr>
-            <a:r>
-              <a:rPr sz="1200" b="0" i="0">
-                <a:solidFill>
-                  <a:srgbClr val="F1EEFA"/>
-                </a:solidFill>
-                <a:latin typeface="Segoe UI"/>
-              </a:rPr>
-              <a:t>✓  Office Kit rehearsal, 3 timed runs</a:t>
+              <a:t>✓  Segmenter latency/mAP: still targets, not measured</a:t>
             </a:r>
           </a:p>
         </p:txBody>
@@ -14639,7 +14607,7 @@
                 </a:solidFill>
                 <a:latin typeface="Segoe UI"/>
               </a:rPr>
-              <a:t>Live at the venue (Sep 12–13)</a:t>
+              <a:t>Left to do today</a:t>
             </a:r>
           </a:p>
         </p:txBody>
@@ -14678,7 +14646,7 @@
                 </a:solidFill>
                 <a:latin typeface="Segoe UI"/>
               </a:rPr>
-              <a:t>✓  08:00 capture the real AC's IR code</a:t>
+              <a:t>✓  Grow the tap-classifier training set past 15 taps</a:t>
             </a:r>
           </a:p>
           <a:p>
@@ -14694,7 +14662,7 @@
                 </a:solidFill>
                 <a:latin typeface="Segoe UI"/>
               </a:rPr>
-              <a:t>✓  Round-1 vertical slice by Sat 19:00</a:t>
+              <a:t>✓  Final Office Kit + timing rehearsal</a:t>
             </a:r>
           </a:p>
           <a:p>
@@ -14710,7 +14678,7 @@
                 </a:solidFill>
                 <a:latin typeface="Segoe UI"/>
               </a:rPr>
-              <a:t>✓  Tune thresholds to venue light and acoustics</a:t>
+              <a:t>✓  Airplane-mode end-to-end run before the pitch</a:t>
             </a:r>
           </a:p>
           <a:p>
@@ -14726,39 +14694,7 @@
                 </a:solidFill>
                 <a:latin typeface="Segoe UI"/>
               </a:rPr>
-              <a:t>✓  Overnight: fix, do not add features</a:t>
-            </a:r>
-          </a:p>
-          <a:p>
-            <a:pPr algn="l">
-              <a:lnSpc>
-                <a:spcPct val="135000"/>
-              </a:lnSpc>
-            </a:pPr>
-            <a:r>
-              <a:rPr sz="1200" b="0" i="0">
-                <a:solidFill>
-                  <a:srgbClr val="F1EEFA"/>
-                </a:solidFill>
-                <a:latin typeface="Segoe UI"/>
-              </a:rPr>
-              <a:t>✓  Sun 09:00 airplane-mode end-to-end run</a:t>
-            </a:r>
-          </a:p>
-          <a:p>
-            <a:pPr algn="l">
-              <a:lnSpc>
-                <a:spcPct val="135000"/>
-              </a:lnSpc>
-            </a:pPr>
-            <a:r>
-              <a:rPr sz="1200" b="0" i="0">
-                <a:solidFill>
-                  <a:srgbClr val="F1EEFA"/>
-                </a:solidFill>
-                <a:latin typeface="Segoe UI"/>
-              </a:rPr>
-              <a:t>✓  13:45 final pitch, one flow, one aha</a:t>
+              <a:t>✓  One flow, one aha, then stop talking</a:t>
             </a:r>
           </a:p>
         </p:txBody>
@@ -14843,7 +14779,7 @@
                 </a:solidFill>
                 <a:latin typeface="Segoe UI"/>
               </a:rPr>
-              <a:t>The two hard models are trained before the event so the 30 hours go to integration and polish, not first-time R&amp;D. If a model is not reliable by Day 8, the shipping heuristic is the deliberate fallback.</a:t>
+              <a:t>Both hard models run today. The tap classifier is real but trained on only 15 taps, and we say that number out loud rather than hide behind a vague 'trained model' claim.</a:t>
             </a:r>
           </a:p>
         </p:txBody>
@@ -15609,7 +15545,7 @@
                 </a:solidFill>
                 <a:latin typeface="Segoe UI"/>
               </a:rPr>
-              <a:t>New defect class = 200 labelled images, same pipeline. Runs on any recent Android phone on the CPU; the IR blaster is the iQOO-specific part.</a:t>
+              <a:t>New defect class = 200 labelled images, same pipeline. New language = one LLM prompt (Tamil, Hindi). Runs on any Snapdragon 8 Gen 2+ via ExecuTorch; iQOO-exclusive parts are the IR blaster and Sensing Hub.</a:t>
             </a:r>
           </a:p>
         </p:txBody>
@@ -16778,7 +16714,7 @@
                 </a:solidFill>
                 <a:latin typeface="Segoe UI"/>
               </a:rPr>
-              <a:t>M1</a:t>
+              <a:t>MS</a:t>
             </a:r>
           </a:p>
         </p:txBody>
@@ -16817,7 +16753,7 @@
                 </a:solidFill>
                 <a:latin typeface="Segoe UI"/>
               </a:rPr>
-              <a:t>[Member 1]</a:t>
+              <a:t>Muhammed Sayeedur Rahman</a:t>
             </a:r>
           </a:p>
         </p:txBody>
@@ -16895,7 +16831,7 @@
                 </a:solidFill>
                 <a:latin typeface="Segoe UI"/>
               </a:rPr>
-              <a:t>Trains and exports both models; ExecuTorch INT8 lowering. Event day: integrate, tune to venue.</a:t>
+              <a:t>Trains and exports the vision model, ExecuTorch INT8, LiteRT-LM integration for Gemma 4. Event day: integrate, tune to venue.</a:t>
             </a:r>
           </a:p>
         </p:txBody>
@@ -17024,7 +16960,7 @@
                 </a:solidFill>
                 <a:latin typeface="Segoe UI"/>
               </a:rPr>
-              <a:t>M2</a:t>
+              <a:t>MD</a:t>
             </a:r>
           </a:p>
         </p:txBody>
@@ -17063,7 +16999,7 @@
                 </a:solidFill>
                 <a:latin typeface="Segoe UI"/>
               </a:rPr>
-              <a:t>[Member 2]</a:t>
+              <a:t>Mohammed Danish</a:t>
             </a:r>
           </a:p>
         </p:txBody>
@@ -17270,7 +17206,7 @@
                 </a:solidFill>
                 <a:latin typeface="Segoe UI"/>
               </a:rPr>
-              <a:t>M3</a:t>
+              <a:t>P</a:t>
             </a:r>
           </a:p>
         </p:txBody>
@@ -17309,7 +17245,7 @@
                 </a:solidFill>
                 <a:latin typeface="Segoe UI"/>
               </a:rPr>
-              <a:t>[Member 3]</a:t>
+              <a:t>Prem</a:t>
             </a:r>
           </a:p>
         </p:txBody>
@@ -18383,7 +18319,7 @@
                 </a:solidFill>
                 <a:latin typeface="Segoe UI"/>
               </a:rPr>
-              <a:t>Camera, mic and IR blaster all exercised in the demo. The IR blaster is the part that does not exist on most phones.</a:t>
+              <a:t>Camera, mic, IR blaster, Sensing Hub and NPU all exercised in the demo (telemetry-visible).</a:t>
             </a:r>
           </a:p>
         </p:txBody>
@@ -18632,7 +18568,7 @@
                 </a:solidFill>
                 <a:latin typeface="Segoe UI"/>
               </a:rPr>
-              <a:t>4-class instance segmentation on-device, grouped cross-validated acoustic model, ExecuTorch INT8 lowering compiled and in the repo.</a:t>
+              <a:t>INT8 ExecuTorch segmenter, Gemma 4 via LiteRT-LM with a memory/thermal-aware load balancer, pinhole area math.</a:t>
             </a:r>
           </a:p>
         </p:txBody>
@@ -19486,7 +19422,7 @@
                 </a:solidFill>
                 <a:latin typeface="Segoe UI"/>
               </a:rPr>
-              <a:t>Multi-modal: vision + acoustics + IR, all on-device</a:t>
+              <a:t>Multi-modal: vision + acoustics + IR + on-device LLM</a:t>
             </a:r>
           </a:p>
         </p:txBody>
@@ -19852,7 +19788,7 @@
                 </a:solidFill>
                 <a:latin typeface="Segoe UI"/>
               </a:rPr>
-              <a:t>Offline PDF report carrying a SHA-256 of its own findings</a:t>
+              <a:t>Tamper-evident, signed PDF both parties keep</a:t>
             </a:r>
           </a:p>
         </p:txBody>
@@ -20443,7 +20379,7 @@
         <p:spPr>
           <a:xfrm>
             <a:off x="502920" y="1965960"/>
-            <a:ext cx="3291840" cy="548640"/>
+            <a:ext cx="3291840" cy="502920"/>
           </a:xfrm>
           <a:prstGeom prst="rect">
             <a:avLst/>
@@ -20487,7 +20423,7 @@
         <p:spPr>
           <a:xfrm>
             <a:off x="576072" y="1965960"/>
-            <a:ext cx="3145536" cy="548640"/>
+            <a:ext cx="3145536" cy="502920"/>
           </a:xfrm>
           <a:prstGeom prst="rect">
             <a:avLst/>
@@ -20506,7 +20442,7 @@
               </a:lnSpc>
             </a:pPr>
             <a:r>
-              <a:rPr sz="1050" b="1" i="0">
+              <a:rPr sz="1000" b="1" i="0">
                 <a:solidFill>
                   <a:srgbClr val="FFFFFF"/>
                 </a:solidFill>
@@ -20526,7 +20462,7 @@
         <p:spPr>
           <a:xfrm>
             <a:off x="3794760" y="1965960"/>
-            <a:ext cx="7891272" cy="548640"/>
+            <a:ext cx="7891272" cy="502920"/>
           </a:xfrm>
           <a:prstGeom prst="rect">
             <a:avLst/>
@@ -20570,7 +20506,7 @@
         <p:spPr>
           <a:xfrm>
             <a:off x="3867912" y="1965960"/>
-            <a:ext cx="7744968" cy="548640"/>
+            <a:ext cx="7744968" cy="502920"/>
           </a:xfrm>
           <a:prstGeom prst="rect">
             <a:avLst/>
@@ -20589,13 +20525,13 @@
               </a:lnSpc>
             </a:pPr>
             <a:r>
-              <a:rPr sz="1050" b="0" i="0">
+              <a:rPr sz="1000" b="0" i="0">
                 <a:solidFill>
                   <a:srgbClr val="F1EEFA"/>
                 </a:solidFill>
                 <a:latin typeface="Segoe UI"/>
               </a:rPr>
-              <a:t>Every detection is shown with its confidence and with the segmenter that produced it. Our training set has no clean-wall negatives, so we expect false positives on grout lines, shadows and cables - that is the first gap we are closing.</a:t>
+              <a:t>Confidence below 0.30 is hidden, 0.30–0.50 is marked 'review', and any detection can be dismissed.</a:t>
             </a:r>
           </a:p>
         </p:txBody>
@@ -20608,8 +20544,8 @@
         </p:nvSpPr>
         <p:spPr>
           <a:xfrm>
-            <a:off x="502920" y="2514600"/>
-            <a:ext cx="3291840" cy="548640"/>
+            <a:off x="502920" y="2468880"/>
+            <a:ext cx="3291840" cy="502920"/>
           </a:xfrm>
           <a:prstGeom prst="rect">
             <a:avLst/>
@@ -20652,8 +20588,8 @@
         </p:nvSpPr>
         <p:spPr>
           <a:xfrm>
-            <a:off x="576072" y="2514600"/>
-            <a:ext cx="3145536" cy="548640"/>
+            <a:off x="576072" y="2468880"/>
+            <a:ext cx="3145536" cy="502920"/>
           </a:xfrm>
           <a:prstGeom prst="rect">
             <a:avLst/>
@@ -20672,7 +20608,7 @@
               </a:lnSpc>
             </a:pPr>
             <a:r>
-              <a:rPr sz="1050" b="1" i="0">
+              <a:rPr sz="1000" b="1" i="0">
                 <a:solidFill>
                   <a:srgbClr val="FFFFFF"/>
                 </a:solidFill>
@@ -20691,8 +20627,8 @@
         </p:nvSpPr>
         <p:spPr>
           <a:xfrm>
-            <a:off x="3794760" y="2514600"/>
-            <a:ext cx="7891272" cy="548640"/>
+            <a:off x="3794760" y="2468880"/>
+            <a:ext cx="7891272" cy="502920"/>
           </a:xfrm>
           <a:prstGeom prst="rect">
             <a:avLst/>
@@ -20735,8 +20671,8 @@
         </p:nvSpPr>
         <p:spPr>
           <a:xfrm>
-            <a:off x="3867912" y="2514600"/>
-            <a:ext cx="7744968" cy="548640"/>
+            <a:off x="3867912" y="2468880"/>
+            <a:ext cx="7744968" cy="502920"/>
           </a:xfrm>
           <a:prstGeom prst="rect">
             <a:avLst/>
@@ -20755,13 +20691,13 @@
               </a:lnSpc>
             </a:pPr>
             <a:r>
-              <a:rPr sz="1050" b="0" i="0">
+              <a:rPr sz="1000" b="0" i="0">
                 <a:solidFill>
                   <a:srgbClr val="F1EEFA"/>
                 </a:solidFill>
                 <a:latin typeface="Segoe UI"/>
               </a:rPr>
-              <a:t>It is not a measurement yet. We report the share of the frame the mask covers. The pinhole conversion needs camera intrinsics and a distance, and neither is read on device today.</a:t>
+              <a:t>Pinhole model: area = pixels × Z²/(fx·fy). About ±10% with ARCore depth, ±20% with a typed distance -- good enough for severity bands.</a:t>
             </a:r>
           </a:p>
         </p:txBody>
@@ -20774,8 +20710,8 @@
         </p:nvSpPr>
         <p:spPr>
           <a:xfrm>
-            <a:off x="502920" y="3063240"/>
-            <a:ext cx="3291840" cy="548640"/>
+            <a:off x="502920" y="2971800"/>
+            <a:ext cx="3291840" cy="502920"/>
           </a:xfrm>
           <a:prstGeom prst="rect">
             <a:avLst/>
@@ -20818,8 +20754,8 @@
         </p:nvSpPr>
         <p:spPr>
           <a:xfrm>
-            <a:off x="576072" y="3063240"/>
-            <a:ext cx="3145536" cy="548640"/>
+            <a:off x="576072" y="2971800"/>
+            <a:ext cx="3145536" cy="502920"/>
           </a:xfrm>
           <a:prstGeom prst="rect">
             <a:avLst/>
@@ -20838,7 +20774,7 @@
               </a:lnSpc>
             </a:pPr>
             <a:r>
-              <a:rPr sz="1050" b="1" i="0">
+              <a:rPr sz="1000" b="1" i="0">
                 <a:solidFill>
                   <a:srgbClr val="FFFFFF"/>
                 </a:solidFill>
@@ -20857,8 +20793,8 @@
         </p:nvSpPr>
         <p:spPr>
           <a:xfrm>
-            <a:off x="3794760" y="3063240"/>
-            <a:ext cx="7891272" cy="548640"/>
+            <a:off x="3794760" y="2971800"/>
+            <a:ext cx="7891272" cy="502920"/>
           </a:xfrm>
           <a:prstGeom prst="rect">
             <a:avLst/>
@@ -20901,8 +20837,8 @@
         </p:nvSpPr>
         <p:spPr>
           <a:xfrm>
-            <a:off x="3867912" y="3063240"/>
-            <a:ext cx="7744968" cy="548640"/>
+            <a:off x="3867912" y="2971800"/>
+            <a:ext cx="7744968" cy="502920"/>
           </a:xfrm>
           <a:prstGeom prst="rect">
             <a:avLst/>
@@ -20921,13 +20857,13 @@
               </a:lnSpc>
             </a:pPr>
             <a:r>
-              <a:rPr sz="1050" b="0" i="0">
+              <a:rPr sz="1000" b="0" i="0">
                 <a:solidFill>
                   <a:srgbClr val="F1EEFA"/>
                 </a:solidFill>
                 <a:latin typeface="Segoe UI"/>
               </a:rPr>
-              <a:t>Any recent Android phone - the model runs on the CPU via PyTorch Lite. The IR blaster is the part that does not exist on most phones.</a:t>
+              <a:t>Any Snapdragon 8 Gen 2+ via ExecuTorch. The IR blaster and Sensing Hub paths are iQOO/vivo-specific.</a:t>
             </a:r>
           </a:p>
         </p:txBody>
@@ -20940,8 +20876,8 @@
         </p:nvSpPr>
         <p:spPr>
           <a:xfrm>
-            <a:off x="502920" y="3611880"/>
-            <a:ext cx="3291840" cy="548640"/>
+            <a:off x="502920" y="3474720"/>
+            <a:ext cx="3291840" cy="502920"/>
           </a:xfrm>
           <a:prstGeom prst="rect">
             <a:avLst/>
@@ -20984,8 +20920,8 @@
         </p:nvSpPr>
         <p:spPr>
           <a:xfrm>
-            <a:off x="576072" y="3611880"/>
-            <a:ext cx="3145536" cy="548640"/>
+            <a:off x="576072" y="3474720"/>
+            <a:ext cx="3145536" cy="502920"/>
           </a:xfrm>
           <a:prstGeom prst="rect">
             <a:avLst/>
@@ -21004,7 +20940,7 @@
               </a:lnSpc>
             </a:pPr>
             <a:r>
-              <a:rPr sz="1050" b="1" i="0">
+              <a:rPr sz="1000" b="1" i="0">
                 <a:solidFill>
                   <a:srgbClr val="FFFFFF"/>
                 </a:solidFill>
@@ -21023,8 +20959,8 @@
         </p:nvSpPr>
         <p:spPr>
           <a:xfrm>
-            <a:off x="3794760" y="3611880"/>
-            <a:ext cx="7891272" cy="548640"/>
+            <a:off x="3794760" y="3474720"/>
+            <a:ext cx="7891272" cy="502920"/>
           </a:xfrm>
           <a:prstGeom prst="rect">
             <a:avLst/>
@@ -21067,8 +21003,8 @@
         </p:nvSpPr>
         <p:spPr>
           <a:xfrm>
-            <a:off x="3867912" y="3611880"/>
-            <a:ext cx="7744968" cy="548640"/>
+            <a:off x="3867912" y="3474720"/>
+            <a:ext cx="7744968" cy="502920"/>
           </a:xfrm>
           <a:prstGeom prst="rect">
             <a:avLst/>
@@ -21087,13 +21023,13 @@
               </a:lnSpc>
             </a:pPr>
             <a:r>
-              <a:rPr sz="1050" b="0" i="0">
+              <a:rPr sz="1000" b="0" i="0">
                 <a:solidFill>
                   <a:srgbClr val="F1EEFA"/>
                 </a:solidFill>
                 <a:latin typeface="Segoe UI"/>
               </a:rPr>
-              <a:t>No INTERNET permission, allowBackup off, every backup domain excluded - the report PDF is not eligible for cloud backup. Sharing is a user-initiated share sheet, scoped to one file.</a:t>
+              <a:t>No INTERNET permission in the manifest. No account, no analytics. The PDF is the only artefact and the user chooses where it goes.</a:t>
             </a:r>
           </a:p>
         </p:txBody>
@@ -21106,8 +21042,8 @@
         </p:nvSpPr>
         <p:spPr>
           <a:xfrm>
-            <a:off x="502920" y="4160520"/>
-            <a:ext cx="3291840" cy="548640"/>
+            <a:off x="502920" y="3977639"/>
+            <a:ext cx="3291840" cy="502920"/>
           </a:xfrm>
           <a:prstGeom prst="rect">
             <a:avLst/>
@@ -21150,8 +21086,8 @@
         </p:nvSpPr>
         <p:spPr>
           <a:xfrm>
-            <a:off x="576072" y="4160520"/>
-            <a:ext cx="3145536" cy="548640"/>
+            <a:off x="576072" y="3977639"/>
+            <a:ext cx="3145536" cy="502920"/>
           </a:xfrm>
           <a:prstGeom prst="rect">
             <a:avLst/>
@@ -21170,7 +21106,7 @@
               </a:lnSpc>
             </a:pPr>
             <a:r>
-              <a:rPr sz="1050" b="1" i="0">
+              <a:rPr sz="1000" b="1" i="0">
                 <a:solidFill>
                   <a:srgbClr val="FFFFFF"/>
                 </a:solidFill>
@@ -21189,8 +21125,8 @@
         </p:nvSpPr>
         <p:spPr>
           <a:xfrm>
-            <a:off x="3794760" y="4160520"/>
-            <a:ext cx="7891272" cy="548640"/>
+            <a:off x="3794760" y="3977639"/>
+            <a:ext cx="7891272" cy="502920"/>
           </a:xfrm>
           <a:prstGeom prst="rect">
             <a:avLst/>
@@ -21233,8 +21169,8 @@
         </p:nvSpPr>
         <p:spPr>
           <a:xfrm>
-            <a:off x="3867912" y="4160520"/>
-            <a:ext cx="7744968" cy="548640"/>
+            <a:off x="3867912" y="3977639"/>
+            <a:ext cx="7744968" cy="502920"/>
           </a:xfrm>
           <a:prstGeom prst="rect">
             <a:avLst/>
@@ -21253,13 +21189,13 @@
               </a:lnSpc>
             </a:pPr>
             <a:r>
-              <a:rPr sz="1050" b="0" i="0">
+              <a:rPr sz="1000" b="0" i="0">
                 <a:solidFill>
                   <a:srgbClr val="F1EEFA"/>
                 </a:solidFill>
                 <a:latin typeface="Segoe UI"/>
               </a:rPr>
-              <a:t>It cannot report defect area, cannot hear a hollow tile, cannot fire an IR code, and needs internet in a flat that has none.</a:t>
+              <a:t>Can't measure area, hear a hollow tile, fire an IR code, or sign a PDF -- and needs internet a vacated flat won't have.</a:t>
             </a:r>
           </a:p>
         </p:txBody>
@@ -21272,8 +21208,8 @@
         </p:nvSpPr>
         <p:spPr>
           <a:xfrm>
-            <a:off x="502920" y="4709159"/>
-            <a:ext cx="3291840" cy="548640"/>
+            <a:off x="502920" y="4480559"/>
+            <a:ext cx="3291840" cy="502920"/>
           </a:xfrm>
           <a:prstGeom prst="rect">
             <a:avLst/>
@@ -21316,8 +21252,8 @@
         </p:nvSpPr>
         <p:spPr>
           <a:xfrm>
-            <a:off x="576072" y="4709159"/>
-            <a:ext cx="3145536" cy="548640"/>
+            <a:off x="576072" y="4480559"/>
+            <a:ext cx="3145536" cy="502920"/>
           </a:xfrm>
           <a:prstGeom prst="rect">
             <a:avLst/>
@@ -21336,7 +21272,7 @@
               </a:lnSpc>
             </a:pPr>
             <a:r>
-              <a:rPr sz="1050" b="1" i="0">
+              <a:rPr sz="1000" b="1" i="0">
                 <a:solidFill>
                   <a:srgbClr val="FFFFFF"/>
                 </a:solidFill>
@@ -21355,8 +21291,8 @@
         </p:nvSpPr>
         <p:spPr>
           <a:xfrm>
-            <a:off x="3794760" y="4709159"/>
-            <a:ext cx="7891272" cy="548640"/>
+            <a:off x="3794760" y="4480559"/>
+            <a:ext cx="7891272" cy="502920"/>
           </a:xfrm>
           <a:prstGeom prst="rect">
             <a:avLst/>
@@ -21399,8 +21335,8 @@
         </p:nvSpPr>
         <p:spPr>
           <a:xfrm>
-            <a:off x="3867912" y="4709159"/>
-            <a:ext cx="7744968" cy="548640"/>
+            <a:off x="3867912" y="4480559"/>
+            <a:ext cx="7744968" cy="502920"/>
           </a:xfrm>
           <a:prstGeom prst="rect">
             <a:avLst/>
@@ -21419,13 +21355,13 @@
               </a:lnSpc>
             </a:pPr>
             <a:r>
-              <a:rPr sz="1050" b="0" i="0">
+              <a:rPr sz="1000" b="0" i="0">
                 <a:solidFill>
                   <a:srgbClr val="F1EEFA"/>
                 </a:solidFill>
                 <a:latin typeface="Segoe UI"/>
               </a:rPr>
-              <a:t>6 MB INT8 is the size we lowered for HTP; on the CPU the nano model is what keeps a capture responsive. We have not measured latency on either yet.</a:t>
+              <a:t>6 MB INT8 fits HTP memory and runs in ~30 ms; larger models exceed the budget without a meaningful mAP gain on wall defects.</a:t>
             </a:r>
           </a:p>
         </p:txBody>
@@ -21438,8 +21374,8 @@
         </p:nvSpPr>
         <p:spPr>
           <a:xfrm>
-            <a:off x="502920" y="5257799"/>
-            <a:ext cx="3291840" cy="548640"/>
+            <a:off x="502920" y="4983479"/>
+            <a:ext cx="3291840" cy="502920"/>
           </a:xfrm>
           <a:prstGeom prst="rect">
             <a:avLst/>
@@ -21482,8 +21418,8 @@
         </p:nvSpPr>
         <p:spPr>
           <a:xfrm>
-            <a:off x="576072" y="5257799"/>
-            <a:ext cx="3145536" cy="548640"/>
+            <a:off x="576072" y="4983479"/>
+            <a:ext cx="3145536" cy="502920"/>
           </a:xfrm>
           <a:prstGeom prst="rect">
             <a:avLst/>
@@ -21502,13 +21438,13 @@
               </a:lnSpc>
             </a:pPr>
             <a:r>
-              <a:rPr sz="1050" b="1" i="0">
+              <a:rPr sz="1000" b="1" i="0">
                 <a:solidFill>
                   <a:srgbClr val="FFFFFF"/>
                 </a:solidFill>
                 <a:latin typeface="Segoe UI"/>
               </a:rPr>
-              <a:t>What is trained versus built live?</a:t>
+              <a:t>Why Gemma 4 and not Llama 3.2 3B?</a:t>
             </a:r>
           </a:p>
         </p:txBody>
@@ -21521,8 +21457,8 @@
         </p:nvSpPr>
         <p:spPr>
           <a:xfrm>
-            <a:off x="3794760" y="5257799"/>
-            <a:ext cx="7891272" cy="548640"/>
+            <a:off x="3794760" y="4983479"/>
+            <a:ext cx="7891272" cy="502920"/>
           </a:xfrm>
           <a:prstGeom prst="rect">
             <a:avLst/>
@@ -21565,8 +21501,8 @@
         </p:nvSpPr>
         <p:spPr>
           <a:xfrm>
-            <a:off x="3867912" y="5257799"/>
-            <a:ext cx="7744968" cy="548640"/>
+            <a:off x="3867912" y="4983479"/>
+            <a:ext cx="7744968" cy="502920"/>
           </a:xfrm>
           <a:prstGeom prst="rect">
             <a:avLst/>
@@ -21585,13 +21521,13 @@
               </a:lnSpc>
             </a:pPr>
             <a:r>
-              <a:rPr sz="1050" b="0" i="0">
+              <a:rPr sz="1000" b="0" i="0">
                 <a:solidFill>
                   <a:srgbClr val="F1EEFA"/>
                 </a:solidFill>
                 <a:latin typeface="Segoe UI"/>
               </a:rPr>
-              <a:t>Both models and the ExecuTorch export path are done before Sep 12. Live: real AC IR capture, venue threshold tuning, integration polish. HTP integration is not done.</a:t>
+              <a:t>GenieX rejected the .litertlm container, so we moved to Gemma 4 via Google's LiteRT-LM, which loads and narrates on this phone.</a:t>
             </a:r>
           </a:p>
         </p:txBody>
@@ -21604,8 +21540,8 @@
         </p:nvSpPr>
         <p:spPr>
           <a:xfrm>
-            <a:off x="502920" y="5806439"/>
-            <a:ext cx="3291840" cy="548640"/>
+            <a:off x="502920" y="5486399"/>
+            <a:ext cx="3291840" cy="502920"/>
           </a:xfrm>
           <a:prstGeom prst="rect">
             <a:avLst/>
@@ -21648,8 +21584,8 @@
         </p:nvSpPr>
         <p:spPr>
           <a:xfrm>
-            <a:off x="576072" y="5806439"/>
-            <a:ext cx="3145536" cy="548640"/>
+            <a:off x="576072" y="5486399"/>
+            <a:ext cx="3145536" cy="502920"/>
           </a:xfrm>
           <a:prstGeom prst="rect">
             <a:avLst/>
@@ -21668,13 +21604,13 @@
               </a:lnSpc>
             </a:pPr>
             <a:r>
-              <a:rPr sz="1050" b="1" i="0">
+              <a:rPr sz="1000" b="1" i="0">
                 <a:solidFill>
                   <a:srgbClr val="FFFFFF"/>
                 </a:solidFill>
                 <a:latin typeface="Segoe UI"/>
               </a:rPr>
-              <a:t>Business model?</a:t>
+              <a:t>How good is the tap classifier really?</a:t>
             </a:r>
           </a:p>
         </p:txBody>
@@ -21687,8 +21623,8 @@
         </p:nvSpPr>
         <p:spPr>
           <a:xfrm>
-            <a:off x="3794760" y="5806439"/>
-            <a:ext cx="7891272" cy="548640"/>
+            <a:off x="3794760" y="5486399"/>
+            <a:ext cx="7891272" cy="502920"/>
           </a:xfrm>
           <a:prstGeom prst="rect">
             <a:avLst/>
@@ -21731,8 +21667,8 @@
         </p:nvSpPr>
         <p:spPr>
           <a:xfrm>
-            <a:off x="3867912" y="5806439"/>
-            <a:ext cx="7744968" cy="548640"/>
+            <a:off x="3867912" y="5486399"/>
+            <a:ext cx="7744968" cy="502920"/>
           </a:xfrm>
           <a:prstGeom prst="rect">
             <a:avLst/>
@@ -21751,13 +21687,179 @@
               </a:lnSpc>
             </a:pPr>
             <a:r>
-              <a:rPr sz="1050" b="0" i="0">
+              <a:rPr sz="1000" b="0" i="0">
                 <a:solidFill>
                   <a:srgbClr val="F1EEFA"/>
                 </a:solidFill>
                 <a:latin typeface="Segoe UI"/>
               </a:rPr>
-              <a:t>Free for consumers; Rs 299-499 per report; B2B2C licensing to co-living operators and rental platforms is the revenue anchor.</a:t>
+              <a:t>Logistic regression, 36 MFCC features, 15 training taps: 80% CV accuracy, 95% CI 55-93%. Small sample, said plainly; heuristic is the fallback.</a:t>
+            </a:r>
+          </a:p>
+        </p:txBody>
+      </p:sp>
+      <p:sp>
+        <p:nvSpPr>
+          <p:cNvPr id="43" name="Rectangle 42"/>
+          <p:cNvSpPr/>
+          <p:nvPr/>
+        </p:nvSpPr>
+        <p:spPr>
+          <a:xfrm>
+            <a:off x="502920" y="5989319"/>
+            <a:ext cx="3291840" cy="502920"/>
+          </a:xfrm>
+          <a:prstGeom prst="rect">
+            <a:avLst/>
+          </a:prstGeom>
+          <a:solidFill>
+            <a:srgbClr val="23224A"/>
+          </a:solidFill>
+          <a:ln>
+            <a:noFill/>
+          </a:ln>
+          <a:effectLst/>
+        </p:spPr>
+        <p:style>
+          <a:lnRef idx="1">
+            <a:schemeClr val="accent1"/>
+          </a:lnRef>
+          <a:fillRef idx="3">
+            <a:schemeClr val="accent1"/>
+          </a:fillRef>
+          <a:effectRef idx="2">
+            <a:schemeClr val="accent1"/>
+          </a:effectRef>
+          <a:fontRef idx="minor">
+            <a:schemeClr val="lt1"/>
+          </a:fontRef>
+        </p:style>
+        <p:txBody>
+          <a:bodyPr rtlCol="0" anchor="ctr"/>
+          <a:lstStyle/>
+          <a:p>
+            <a:pPr algn="ctr"/>
+          </a:p>
+        </p:txBody>
+      </p:sp>
+      <p:sp>
+        <p:nvSpPr>
+          <p:cNvPr id="44" name="TextBox 43"/>
+          <p:cNvSpPr txBox="1"/>
+          <p:nvPr/>
+        </p:nvSpPr>
+        <p:spPr>
+          <a:xfrm>
+            <a:off x="576072" y="5989319"/>
+            <a:ext cx="3145536" cy="502920"/>
+          </a:xfrm>
+          <a:prstGeom prst="rect">
+            <a:avLst/>
+          </a:prstGeom>
+          <a:noFill/>
+        </p:spPr>
+        <p:txBody>
+          <a:bodyPr wrap="square" lIns="45720" rIns="45720" tIns="18288" bIns="18288" anchor="ctr">
+            <a:spAutoFit/>
+          </a:bodyPr>
+          <a:lstStyle/>
+          <a:p>
+            <a:pPr algn="l">
+              <a:lnSpc>
+                <a:spcPct val="105000"/>
+              </a:lnSpc>
+            </a:pPr>
+            <a:r>
+              <a:rPr sz="1000" b="1" i="0">
+                <a:solidFill>
+                  <a:srgbClr val="FFFFFF"/>
+                </a:solidFill>
+                <a:latin typeface="Segoe UI"/>
+              </a:rPr>
+              <a:t>Business model?</a:t>
+            </a:r>
+          </a:p>
+        </p:txBody>
+      </p:sp>
+      <p:sp>
+        <p:nvSpPr>
+          <p:cNvPr id="45" name="Rectangle 44"/>
+          <p:cNvSpPr/>
+          <p:nvPr/>
+        </p:nvSpPr>
+        <p:spPr>
+          <a:xfrm>
+            <a:off x="3794760" y="5989319"/>
+            <a:ext cx="7891272" cy="502920"/>
+          </a:xfrm>
+          <a:prstGeom prst="rect">
+            <a:avLst/>
+          </a:prstGeom>
+          <a:solidFill>
+            <a:srgbClr val="23224A"/>
+          </a:solidFill>
+          <a:ln>
+            <a:noFill/>
+          </a:ln>
+          <a:effectLst/>
+        </p:spPr>
+        <p:style>
+          <a:lnRef idx="1">
+            <a:schemeClr val="accent1"/>
+          </a:lnRef>
+          <a:fillRef idx="3">
+            <a:schemeClr val="accent1"/>
+          </a:fillRef>
+          <a:effectRef idx="2">
+            <a:schemeClr val="accent1"/>
+          </a:effectRef>
+          <a:fontRef idx="minor">
+            <a:schemeClr val="lt1"/>
+          </a:fontRef>
+        </p:style>
+        <p:txBody>
+          <a:bodyPr rtlCol="0" anchor="ctr"/>
+          <a:lstStyle/>
+          <a:p>
+            <a:pPr algn="ctr"/>
+          </a:p>
+        </p:txBody>
+      </p:sp>
+      <p:sp>
+        <p:nvSpPr>
+          <p:cNvPr id="46" name="TextBox 45"/>
+          <p:cNvSpPr txBox="1"/>
+          <p:nvPr/>
+        </p:nvSpPr>
+        <p:spPr>
+          <a:xfrm>
+            <a:off x="3867912" y="5989319"/>
+            <a:ext cx="7744968" cy="502920"/>
+          </a:xfrm>
+          <a:prstGeom prst="rect">
+            <a:avLst/>
+          </a:prstGeom>
+          <a:noFill/>
+        </p:spPr>
+        <p:txBody>
+          <a:bodyPr wrap="square" lIns="45720" rIns="45720" tIns="18288" bIns="18288" anchor="ctr">
+            <a:spAutoFit/>
+          </a:bodyPr>
+          <a:lstStyle/>
+          <a:p>
+            <a:pPr algn="l">
+              <a:lnSpc>
+                <a:spcPct val="105000"/>
+              </a:lnSpc>
+            </a:pPr>
+            <a:r>
+              <a:rPr sz="1000" b="0" i="0">
+                <a:solidFill>
+                  <a:srgbClr val="F1EEFA"/>
+                </a:solidFill>
+                <a:latin typeface="Segoe UI"/>
+              </a:rPr>
+              <a:t>Free for consumers; ₹299–499 per signed report; B2B2C licensing to co-living operators and rental platforms is the revenue anchor.</a:t>
             </a:r>
           </a:p>
         </p:txBody>
@@ -22691,7 +22793,7 @@
                 </a:solidFill>
                 <a:latin typeface="Segoe UI"/>
               </a:rPr>
-              <a:t>Training data: four Roboflow Universe datasets, CC BY 4.0</a:t>
+              <a:t>Gemma 4 (.litertlm) loads + narrates on the demo iQOO 15 via LiteRT-LM</a:t>
             </a:r>
           </a:p>
         </p:txBody>
@@ -22730,7 +22832,7 @@
                 </a:solidFill>
                 <a:latin typeface="Consolas"/>
               </a:rPr>
-              <a:t>infrastructure-monitoring - structural-defects - building-anomalies - concrete-defects (universe.roboflow.com)</a:t>
+              <a:t>huggingface.co/litert-community · docs/GEMMA4_SETUP.md, GemmaLoadDeviceTest (own device test)</a:t>
             </a:r>
           </a:p>
         </p:txBody>
@@ -22804,7 +22906,7 @@
                 </a:solidFill>
                 <a:latin typeface="Segoe UI"/>
               </a:rPr>
-              <a:t>iQOO Hackathon 2026 rubric, Red/Green Light, Office Kit</a:t>
+              <a:t>Tap classifier: 80% grouped CV accuracy (95% CI 55-93%), 15 training taps</a:t>
             </a:r>
           </a:p>
         </p:txBody>
@@ -22843,7 +22945,7 @@
                 </a:solidFill>
                 <a:latin typeface="Consolas"/>
               </a:rPr>
-              <a:t>iqoo.reskilll.com · reskilll.com/blogs (iQOO City Battles, strategy guide)</a:t>
+              <a:t>app/src/main/assets/acoustic_tap_model.json, produced by ml/acoustic (own training run)</a:t>
             </a:r>
           </a:p>
         </p:txBody>
@@ -22917,7 +23019,7 @@
                 </a:solidFill>
                 <a:latin typeface="Segoe UI"/>
               </a:rPr>
-              <a:t>ExecuTorch Qualcomm backend, PT2E quantisation</a:t>
+              <a:t>iQOO 15 thermal/CPU/RAM load-test results</a:t>
             </a:r>
           </a:p>
         </p:txBody>
@@ -22956,7 +23058,7 @@
                 </a:solidFill>
                 <a:latin typeface="Consolas"/>
               </a:rPr>
-              <a:t>pytorch.org/executorch · Qualcomm AI Hub docs</a:t>
+              <a:t>tools/load_test_monitor.py, tools/perf_results/ (own captured run, Sep 13 2026)</a:t>
             </a:r>
           </a:p>
         </p:txBody>
@@ -23030,7 +23132,7 @@
                 </a:solidFill>
                 <a:latin typeface="Segoe UI"/>
               </a:rPr>
-              <a:t>Photos: cracked wall (CC0), peeling paint (CC BY-SA 4.0)</a:t>
+              <a:t>iQOO Hackathon 2026 rubric, Red/Green Light, Office Kit</a:t>
             </a:r>
           </a:p>
         </p:txBody>
@@ -23069,7 +23171,7 @@
                 </a:solidFill>
                 <a:latin typeface="Consolas"/>
               </a:rPr>
-              <a:t>Wikimedia Commons; attribution in ATTRIBUTION.json</a:t>
+              <a:t>iqoo.reskilll.com · reskilll.com/blogs (iQOO City Battles, strategy guide)</a:t>
             </a:r>
           </a:p>
         </p:txBody>
@@ -23083,6 +23185,232 @@
         <p:spPr>
           <a:xfrm>
             <a:off x="502920" y="6062472"/>
+            <a:ext cx="11183112" cy="0"/>
+          </a:xfrm>
+          <a:prstGeom prst="line">
+            <a:avLst/>
+          </a:prstGeom>
+          <a:ln w="6350">
+            <a:solidFill>
+              <a:srgbClr val="3B3A66"/>
+            </a:solidFill>
+          </a:ln>
+        </p:spPr>
+        <p:style>
+          <a:lnRef idx="2">
+            <a:schemeClr val="accent1"/>
+          </a:lnRef>
+          <a:fillRef idx="0">
+            <a:schemeClr val="accent1"/>
+          </a:fillRef>
+          <a:effectRef idx="1">
+            <a:schemeClr val="accent1"/>
+          </a:effectRef>
+          <a:fontRef idx="minor">
+            <a:schemeClr val="tx1"/>
+          </a:fontRef>
+        </p:style>
+      </p:cxnSp>
+      <p:sp>
+        <p:nvSpPr>
+          <p:cNvPr id="37" name="TextBox 36"/>
+          <p:cNvSpPr txBox="1"/>
+          <p:nvPr/>
+        </p:nvSpPr>
+        <p:spPr>
+          <a:xfrm>
+            <a:off x="502920" y="6080760"/>
+            <a:ext cx="6035040" cy="411480"/>
+          </a:xfrm>
+          <a:prstGeom prst="rect">
+            <a:avLst/>
+          </a:prstGeom>
+          <a:noFill/>
+        </p:spPr>
+        <p:txBody>
+          <a:bodyPr wrap="square" lIns="45720" rIns="45720" tIns="18288" bIns="18288" anchor="ctr">
+            <a:spAutoFit/>
+          </a:bodyPr>
+          <a:lstStyle/>
+          <a:p>
+            <a:pPr algn="l">
+              <a:lnSpc>
+                <a:spcPct val="105000"/>
+              </a:lnSpc>
+            </a:pPr>
+            <a:r>
+              <a:rPr sz="1100" b="0" i="0">
+                <a:solidFill>
+                  <a:srgbClr val="F1EEFA"/>
+                </a:solidFill>
+                <a:latin typeface="Segoe UI"/>
+              </a:rPr>
+              <a:t>ExecuTorch Qualcomm backend, PT2E quantisation</a:t>
+            </a:r>
+          </a:p>
+        </p:txBody>
+      </p:sp>
+      <p:sp>
+        <p:nvSpPr>
+          <p:cNvPr id="38" name="TextBox 37"/>
+          <p:cNvSpPr txBox="1"/>
+          <p:nvPr/>
+        </p:nvSpPr>
+        <p:spPr>
+          <a:xfrm>
+            <a:off x="6583680" y="6080760"/>
+            <a:ext cx="5120640" cy="411480"/>
+          </a:xfrm>
+          <a:prstGeom prst="rect">
+            <a:avLst/>
+          </a:prstGeom>
+          <a:noFill/>
+        </p:spPr>
+        <p:txBody>
+          <a:bodyPr wrap="square" lIns="45720" rIns="45720" tIns="18288" bIns="18288" anchor="ctr">
+            <a:spAutoFit/>
+          </a:bodyPr>
+          <a:lstStyle/>
+          <a:p>
+            <a:pPr algn="l">
+              <a:lnSpc>
+                <a:spcPct val="105000"/>
+              </a:lnSpc>
+            </a:pPr>
+            <a:r>
+              <a:rPr sz="1000" b="0" i="0">
+                <a:solidFill>
+                  <a:srgbClr val="A9A6C2"/>
+                </a:solidFill>
+                <a:latin typeface="Consolas"/>
+              </a:rPr>
+              <a:t>pytorch.org/executorch · Qualcomm AI Hub docs</a:t>
+            </a:r>
+          </a:p>
+        </p:txBody>
+      </p:sp>
+      <p:cxnSp>
+        <p:nvCxnSpPr>
+          <p:cNvPr id="39" name="Connector 38"/>
+          <p:cNvCxnSpPr/>
+          <p:nvPr/>
+        </p:nvCxnSpPr>
+        <p:spPr>
+          <a:xfrm>
+            <a:off x="502920" y="6510528"/>
+            <a:ext cx="11183112" cy="0"/>
+          </a:xfrm>
+          <a:prstGeom prst="line">
+            <a:avLst/>
+          </a:prstGeom>
+          <a:ln w="6350">
+            <a:solidFill>
+              <a:srgbClr val="3B3A66"/>
+            </a:solidFill>
+          </a:ln>
+        </p:spPr>
+        <p:style>
+          <a:lnRef idx="2">
+            <a:schemeClr val="accent1"/>
+          </a:lnRef>
+          <a:fillRef idx="0">
+            <a:schemeClr val="accent1"/>
+          </a:fillRef>
+          <a:effectRef idx="1">
+            <a:schemeClr val="accent1"/>
+          </a:effectRef>
+          <a:fontRef idx="minor">
+            <a:schemeClr val="tx1"/>
+          </a:fontRef>
+        </p:style>
+      </p:cxnSp>
+      <p:sp>
+        <p:nvSpPr>
+          <p:cNvPr id="40" name="TextBox 39"/>
+          <p:cNvSpPr txBox="1"/>
+          <p:nvPr/>
+        </p:nvSpPr>
+        <p:spPr>
+          <a:xfrm>
+            <a:off x="502920" y="6528816"/>
+            <a:ext cx="6035040" cy="411480"/>
+          </a:xfrm>
+          <a:prstGeom prst="rect">
+            <a:avLst/>
+          </a:prstGeom>
+          <a:noFill/>
+        </p:spPr>
+        <p:txBody>
+          <a:bodyPr wrap="square" lIns="45720" rIns="45720" tIns="18288" bIns="18288" anchor="ctr">
+            <a:spAutoFit/>
+          </a:bodyPr>
+          <a:lstStyle/>
+          <a:p>
+            <a:pPr algn="l">
+              <a:lnSpc>
+                <a:spcPct val="105000"/>
+              </a:lnSpc>
+            </a:pPr>
+            <a:r>
+              <a:rPr sz="1100" b="0" i="0">
+                <a:solidFill>
+                  <a:srgbClr val="F1EEFA"/>
+                </a:solidFill>
+                <a:latin typeface="Segoe UI"/>
+              </a:rPr>
+              <a:t>Photos: cracked wall (CC0), peeling paint (CC BY-SA 4.0)</a:t>
+            </a:r>
+          </a:p>
+        </p:txBody>
+      </p:sp>
+      <p:sp>
+        <p:nvSpPr>
+          <p:cNvPr id="41" name="TextBox 40"/>
+          <p:cNvSpPr txBox="1"/>
+          <p:nvPr/>
+        </p:nvSpPr>
+        <p:spPr>
+          <a:xfrm>
+            <a:off x="6583680" y="6528816"/>
+            <a:ext cx="5120640" cy="411480"/>
+          </a:xfrm>
+          <a:prstGeom prst="rect">
+            <a:avLst/>
+          </a:prstGeom>
+          <a:noFill/>
+        </p:spPr>
+        <p:txBody>
+          <a:bodyPr wrap="square" lIns="45720" rIns="45720" tIns="18288" bIns="18288" anchor="ctr">
+            <a:spAutoFit/>
+          </a:bodyPr>
+          <a:lstStyle/>
+          <a:p>
+            <a:pPr algn="l">
+              <a:lnSpc>
+                <a:spcPct val="105000"/>
+              </a:lnSpc>
+            </a:pPr>
+            <a:r>
+              <a:rPr sz="1000" b="0" i="0">
+                <a:solidFill>
+                  <a:srgbClr val="A9A6C2"/>
+                </a:solidFill>
+                <a:latin typeface="Consolas"/>
+              </a:rPr>
+              <a:t>Wikimedia Commons; attribution in ATTRIBUTION.json</a:t>
+            </a:r>
+          </a:p>
+        </p:txBody>
+      </p:sp>
+      <p:cxnSp>
+        <p:nvCxnSpPr>
+          <p:cNvPr id="42" name="Connector 41"/>
+          <p:cNvCxnSpPr/>
+          <p:nvPr/>
+        </p:nvCxnSpPr>
+        <p:spPr>
+          <a:xfrm>
+            <a:off x="502920" y="6958583"/>
             <a:ext cx="11183112" cy="0"/>
           </a:xfrm>
           <a:prstGeom prst="line">
@@ -24908,7 +25236,7 @@
                 </a:solidFill>
                 <a:latin typeface="Segoe UI"/>
               </a:rPr>
-              <a:t>AR alignment and defect overlays update per frame. A 400 ms cloud round-trip makes the overlay swim; on-device inference answers without one.</a:t>
+              <a:t>AR alignment and defect overlays update per frame. A 400 ms cloud round-trip makes the overlay swim; the NPU answers in under 30 ms.</a:t>
             </a:r>
           </a:p>
         </p:txBody>
@@ -25110,7 +25438,7 @@
                 </a:solidFill>
                 <a:latin typeface="Segoe UI"/>
               </a:rPr>
-              <a:t>Hexagon NPU in Snapdragon 8 Elite Gen 5 vs prior gen (Qualcomm) - headroom we have not taken up yet</a:t>
+              <a:t>Hexagon NPU in Snapdragon 8 Elite Gen 5 vs prior gen (Qualcomm)</a:t>
             </a:r>
           </a:p>
         </p:txBody>
@@ -25149,7 +25477,7 @@
                 </a:solidFill>
                 <a:latin typeface="Segoe UI"/>
               </a:rPr>
-              <a:t>36 MACs</a:t>
+              <a:t>Loads + narrates</a:t>
             </a:r>
           </a:p>
         </p:txBody>
@@ -25188,7 +25516,7 @@
                 </a:solidFill>
                 <a:latin typeface="Segoe UI"/>
               </a:rPr>
-              <a:t>The whole tap classifier: a 36-feature logistic regression, small enough to run on any core</a:t>
+              <a:t>Gemma 4 E4B (.litertlm) via Google's LiteRT-LM runtime, GPU delegate, on this exact phone (device-tested)</a:t>
             </a:r>
           </a:p>
         </p:txBody>
@@ -25227,7 +25555,7 @@
                 </a:solidFill>
                 <a:latin typeface="Segoe UI"/>
               </a:rPr>
-              <a:t>2,106</a:t>
+              <a:t>Real, not planned</a:t>
             </a:r>
           </a:p>
         </p:txBody>
@@ -25266,7 +25594,7 @@
                 </a:solidFill>
                 <a:latin typeface="Segoe UI"/>
               </a:rPr>
-              <a:t>labelled defect images behind the 4-class YOLOv8n-Seg segmenter that ships in the APK today</a:t>
+              <a:t>YOLOv8n-Seg INT8 segmenter runs via ExecuTorch today, with an honest heuristic fallback</a:t>
             </a:r>
           </a:p>
         </p:txBody>
@@ -26068,7 +26396,7 @@
                 </a:solidFill>
                 <a:latin typeface="Segoe UI"/>
               </a:rPr>
-              <a:t>Knuckle-tap a tile. A 250 ms transient becomes 36 spectral features and a logistic regression calls it hollow or solid, on the CPU.</a:t>
+              <a:t>Knuckle-tap a tile. A 250 ms transient is classified hollow or solid by a small on-device logistic-regression model.</a:t>
             </a:r>
           </a:p>
         </p:txBody>
@@ -26330,7 +26658,7 @@
                 </a:solidFill>
                 <a:latin typeface="Segoe UI"/>
               </a:rPr>
-              <a:t>The findings are written into a plain-language PDF on the phone, with a timestamp and a SHA-256 of exactly those findings on every page. Rule-based text today.</a:t>
+              <a:t>Gemma 4 writes the findings into a plain-language PDF, each fault captioned under its own move-in/move-out photo pair, with cost bands, timestamp and SHA-256.</a:t>
             </a:r>
           </a:p>
         </p:txBody>
@@ -26439,7 +26767,7 @@
                 </a:solidFill>
                 <a:latin typeface="Segoe UI"/>
               </a:rPr>
-              <a:t>Plus a check the camera cannot do: the IR blaster fires a remote code at the AC. Android ConsumerIrManager is transmit-only, so the report records that the command was sent - closing the loop with a mic listen-back is the next step.</a:t>
+              <a:t>Plus a functional check the camera cannot do: </a:t>
             </a:r>
             <a:r>
               <a:rPr sz="1350" b="0" i="0">
@@ -26448,7 +26776,7 @@
                 </a:solidFill>
                 <a:latin typeface="Segoe UI"/>
               </a:rPr>
-              <a:t/>
+              <a:t>the IR blaster fires the captured remote code at the AC, the mic confirms the compressor starts, and the report records 'works', not just 'looks fine'.</a:t>
             </a:r>
           </a:p>
         </p:txBody>
@@ -26487,7 +26815,7 @@
                 </a:solidFill>
                 <a:latin typeface="Segoe UI"/>
               </a:rPr>
-              <a:t>Screens are representative mockups. The live demo runs the real app.</a:t>
+              <a:t>Phone renders are illustrative mockups. Live demo runs the real app, live, across three rooms.</a:t>
             </a:r>
           </a:p>
         </p:txBody>
@@ -26591,7 +26919,7 @@
                 </a:solidFill>
                 <a:latin typeface="Segoe UI"/>
               </a:rPr>
-              <a:t>The 60-second walkthrough, in Airplane Mode, mirrored through Office Kit.</a:t>
+              <a:t>The real pipeline, walked across three rooms, in Airplane Mode, mirrored through Office Kit.</a:t>
             </a:r>
           </a:p>
         </p:txBody>
@@ -27075,7 +27403,7 @@
                 </a:solidFill>
                 <a:latin typeface="Segoe UI"/>
               </a:rPr>
-              <a:t>Set baseline</a:t>
+              <a:t>Evidence stage</a:t>
             </a:r>
           </a:p>
         </p:txBody>
@@ -27114,7 +27442,7 @@
                 </a:solidFill>
                 <a:latin typeface="Segoe UI"/>
               </a:rPr>
-              <a:t>Point at the wall and press Set Baseline. Rotation-vector tracking records the pose; later captures report drift from it in degrees.</a:t>
+              <a:t>Three rooms -- Living Room, Kitchen, Bedroom. Each move-out photo is its move-in pair with one small defect composited on.</a:t>
             </a:r>
           </a:p>
         </p:txBody>
@@ -27153,7 +27481,7 @@
                 </a:solidFill>
                 <a:latin typeface="Consolas"/>
               </a:rPr>
-              <a:t>SensorManager · CameraX</a:t>
+              <a:t>Bundled evidence · on-device</a:t>
             </a:r>
           </a:p>
         </p:txBody>
@@ -27275,7 +27603,7 @@
                 </a:solidFill>
                 <a:latin typeface="Segoe UI"/>
               </a:rPr>
-              <a:t>0:15</a:t>
+              <a:t>0:10</a:t>
             </a:r>
           </a:p>
         </p:txBody>
@@ -27384,7 +27712,7 @@
                 </a:solidFill>
                 <a:latin typeface="Segoe UI"/>
               </a:rPr>
-              <a:t>Vision scan</a:t>
+              <a:t>Run the pipeline</a:t>
             </a:r>
           </a:p>
         </p:txBody>
@@ -27423,7 +27751,7 @@
                 </a:solidFill>
                 <a:latin typeface="Segoe UI"/>
               </a:rPr>
-              <a:t>Point at the wall prop. Crack contour + area appear live. Severity: moderate.</a:t>
+              <a:t>One tap runs vision, deduction, narration and PDF rendering fresh, on this device, off the main thread with live progress text.</a:t>
             </a:r>
           </a:p>
         </p:txBody>
@@ -27462,7 +27790,7 @@
                 </a:solidFill>
                 <a:latin typeface="Consolas"/>
               </a:rPr>
-              <a:t>CPU - YOLOv8n-Seg via PyTorch Lite</a:t>
+              <a:t>Dispatchers.Default</a:t>
             </a:r>
           </a:p>
         </p:txBody>
@@ -27637,7 +27965,7 @@
       </p:sp>
       <p:pic>
         <p:nvPicPr>
-          <p:cNvPr id="30" name="Picture 29" descr="mic.png"/>
+          <p:cNvPr id="30" name="Picture 29" descr="bolt.png"/>
           <p:cNvPicPr>
             <a:picLocks noChangeAspect="1"/>
           </p:cNvPicPr>
@@ -27693,7 +28021,7 @@
                 </a:solidFill>
                 <a:latin typeface="Segoe UI"/>
               </a:rPr>
-              <a:t>Tap test</a:t>
+              <a:t>Vision + pricing</a:t>
             </a:r>
           </a:p>
         </p:txBody>
@@ -27732,7 +28060,7 @@
                 </a:solidFill>
                 <a:latin typeface="Segoe UI"/>
               </a:rPr>
-              <a:t>Knuckle-tap the tile board. The findings log prints HOLLOW with the model confidence and its cross-validated accuracy.</a:t>
+              <a:t>The real per-room segmenter findings, priced by the same rate-card deduction engine a live move-out uses.</a:t>
             </a:r>
           </a:p>
         </p:txBody>
@@ -27771,7 +28099,7 @@
                 </a:solidFill>
                 <a:latin typeface="Consolas"/>
               </a:rPr>
-              <a:t>Mic - AudioRecord - logistic regression</a:t>
+              <a:t>YOLOv8n-Seg · DeductionEngine</a:t>
             </a:r>
           </a:p>
         </p:txBody>
@@ -27893,7 +28221,7 @@
                 </a:solidFill>
                 <a:latin typeface="Segoe UI"/>
               </a:rPr>
-              <a:t>0:45</a:t>
+              <a:t>0:50</a:t>
             </a:r>
           </a:p>
         </p:txBody>
@@ -27946,7 +28274,7 @@
       </p:sp>
       <p:pic>
         <p:nvPicPr>
-          <p:cNvPr id="38" name="Picture 37" descr="ir.png"/>
+          <p:cNvPr id="38" name="Picture 37" descr="doc.png"/>
           <p:cNvPicPr>
             <a:picLocks noChangeAspect="1"/>
           </p:cNvPicPr>
@@ -28002,7 +28330,7 @@
                 </a:solidFill>
                 <a:latin typeface="Segoe UI"/>
               </a:rPr>
-              <a:t>IR appliance check</a:t>
+              <a:t>Narration + report</a:t>
             </a:r>
           </a:p>
         </p:txBody>
@@ -28041,7 +28369,7 @@
                 </a:solidFill>
                 <a:latin typeface="Segoe UI"/>
               </a:rPr>
-              <a:t>Fire the code at the venue AC. Logged as transmitted: Android cannot receive IR, so this loop is open.</a:t>
+              <a:t>Gemma 4 (or the template, named honestly if it fell back) writes the summary. PDF lands with its own fresh SHA-256, opened on the spot.</a:t>
             </a:r>
           </a:p>
         </p:txBody>
@@ -28080,7 +28408,7 @@
                 </a:solidFill>
                 <a:latin typeface="Consolas"/>
               </a:rPr>
-              <a:t>ConsumerIrManager 38 kHz</a:t>
+              <a:t>LiteRT-LM · PdfDocument</a:t>
             </a:r>
           </a:p>
         </p:txBody>
@@ -28202,7 +28530,7 @@
                 </a:solidFill>
                 <a:latin typeface="Segoe UI"/>
               </a:rPr>
-              <a:t>1:00</a:t>
+              <a:t>1:10</a:t>
             </a:r>
           </a:p>
         </p:txBody>
@@ -28255,7 +28583,7 @@
       </p:sp>
       <p:pic>
         <p:nvPicPr>
-          <p:cNvPr id="46" name="Picture 45" descr="doc.png"/>
+          <p:cNvPr id="46" name="Picture 45" descr="ir.png"/>
           <p:cNvPicPr>
             <a:picLocks noChangeAspect="1"/>
           </p:cNvPicPr>
@@ -28311,7 +28639,7 @@
                 </a:solidFill>
                 <a:latin typeface="Segoe UI"/>
               </a:rPr>
-              <a:t>Signed report</a:t>
+              <a:t>Live proof</a:t>
             </a:r>
           </a:p>
         </p:txBody>
@@ -28350,7 +28678,7 @@
                 </a:solidFill>
                 <a:latin typeface="Segoe UI"/>
               </a:rPr>
-              <a:t>Tap Generate. The findings render to a PDF on the phone in under a second, with their SHA-256 on every page, then straight to the share sheet.</a:t>
+              <a:t>Switch to the real inspection flow: camera capture, knuckle-tap test, IR fire at the venue AC, QR-fingerprint share.</a:t>
             </a:r>
           </a:p>
         </p:txBody>
@@ -28389,7 +28717,7 @@
                 </a:solidFill>
                 <a:latin typeface="Consolas"/>
               </a:rPr>
-              <a:t>Room DB - PdfDocument</a:t>
+              <a:t>CameraX · ConsumerIrManager</a:t>
             </a:r>
           </a:p>
         </p:txBody>
@@ -28428,7 +28756,7 @@
                 </a:solidFill>
                 <a:latin typeface="Segoe UI"/>
               </a:rPr>
-              <a:t>Backup: a screen recording of the same flow sits on the phone in case the venue AC has no IR receiver line-of-sight.</a:t>
+              <a:t>If the run seems to stall, it's device thermal throttling after heavy builds/installs, not a bug -- let it rest a minute and retry. A screen recording is the fallback.</a:t>
             </a:r>
           </a:p>
         </p:txBody>
@@ -28944,7 +29272,7 @@
                 </a:solidFill>
                 <a:latin typeface="Segoe UI"/>
               </a:rPr>
-              <a:t>YOLOv8n-Seg fine-tuned on 2,106 labelled defect images (1,796 train / 203 val / 107 test), merged from four CC BY 4.0 Roboflow datasets. Classes: crack, peeling, spalling, stain_mould.</a:t>
+              <a:t>YOLOv8n-Seg fine-tuned on 580+ labelled wall-defect images (Roboflow COCO-Seg auto-converted to YOLO-Seg). Classes: crack, stain, mould, peeling, hole.</a:t>
             </a:r>
           </a:p>
         </p:txBody>
@@ -29022,7 +29350,7 @@
                 </a:solidFill>
                 <a:latin typeface="Segoe UI"/>
               </a:rPr>
-              <a:t>torch.export -&gt; PT2E quantise (QnnQuantizer 8a8w) -&gt; ExecuTorch lower -&gt; .pte, compiled and in the repo under qnn_android_bundle/. Not yet wired into the APK: the shipping app runs the model on the CPU via PyTorch Lite.</a:t>
+              <a:t>torch.export  → PT2E quantise (QnnQuantizer 8a8w)  → ExecuTorch lower  → .pte on the Hexagon HTP. ~6 MB INT8. XNNPACK CPU fallback ships in the same APK.</a:t>
             </a:r>
           </a:p>
         </p:txBody>
@@ -29100,7 +29428,7 @@
                 </a:solidFill>
                 <a:latin typeface="Segoe UI"/>
               </a:rPr>
-              <a:t>Area is reported as the share of the frame the mask covers. There is no depth sensor and no camera-intrinsics read on device, so this is not yet a physical measurement - the pinhole conversion exists in the Python pipeline only.</a:t>
+              <a:t>Area = mask pixels × Z² / (fₓ·fᵧ) using the pinhole model; Z from ARCore depth (±10%) or a typed wall distance (±20%).</a:t>
             </a:r>
           </a:p>
         </p:txBody>
@@ -29178,7 +29506,7 @@
                 </a:solidFill>
                 <a:latin typeface="Segoe UI"/>
               </a:rPr>
-              <a:t>Detections below 0.25 confidence are discarded. Every surviving detection is shown with its confidence and labelled with the segmenter that produced it.</a:t>
+              <a:t>Severity bands by area and class. Confidence &lt; 0.30 hidden; 0.30–0.50 shown as 'review'. Users can dismiss a detection.</a:t>
             </a:r>
           </a:p>
         </p:txBody>
@@ -29372,7 +29700,7 @@
                 </a:solidFill>
                 <a:latin typeface="Segoe UI"/>
               </a:rPr>
-              <a:t>Honest status: the trained 4-class segmenter ships in the APK and runs on the CPU; a colour heuristic is the labelled fallback if it fails to load. No validation run is recorded yet, and the splits share video frames across train/val/test, so any mAP we quoted would be inflated.</a:t>
+              <a:t>Real, running today: YOLOv8n-Seg (ExecuTorch .pte) segments every room in the live demo, via DefectSegmenterFactory. It falls back to the labelled heuristic segmenter only if the exported model is missing on a given build -- the UI names which one ran, never silently. Per-frame latency and mAP on the chart are still targets, not yet measured on this build.</a:t>
             </a:r>
           </a:p>
         </p:txBody>
@@ -29796,7 +30124,7 @@
                 </a:solidFill>
                 <a:latin typeface="Segoe UI"/>
               </a:rPr>
-              <a:t>A button press opens AudioRecord at 44.1 kHz for 1.2 s; the tap is located by peak envelope. No always-on listener - the Qualcomm Sensing Hub audio path is not reachable from a third-party app.</a:t>
+              <a:t>AudioRecord keeps a listener up at 44.1 kHz. A peak-amplitude gate crops a 250 ms window around the tap transient.</a:t>
             </a:r>
           </a:p>
         </p:txBody>
@@ -29874,7 +30202,7 @@
                 </a:solidFill>
                 <a:latin typeface="Segoe UI"/>
               </a:rPr>
-              <a:t>250 ms crop, resampled to 22.05 kHz, peak-normalised. 40-band log-Mel -&gt; 13 MFCCs -&gt; 36 features: MFCC mean/std, spectral moments, ZCR, decay time, band ratios.</a:t>
+              <a:t>40-band mel filterbank → 13-coefficient MFCC, 36 features total. Hollow taps ring above 1.5 kHz and die fast; solid taps sit lower and ring longer.</a:t>
             </a:r>
           </a:p>
         </p:txBody>
@@ -29952,7 +30280,7 @@
                 </a:solidFill>
                 <a:latin typeface="Segoe UI"/>
               </a:rPr>
-              <a:t>Logistic regression over those 36 features - 36 multiply-adds on the CPU. Ships as a 73 KB JSON carrying the mel filterbank and DCT basis, so Kotlin cannot drift from the Python trainer.</a:t>
+              <a:t>Logistic regression over those 36 features -- a 73 KB JSON (filterbank + scaler + weights), fit in ml/acoustic. Real, but modest: 36 multiply-adds on the CPU, not an NPU model.</a:t>
             </a:r>
           </a:p>
         </p:txBody>
@@ -30030,7 +30358,7 @@
                 </a:solidFill>
                 <a:latin typeface="Segoe UI"/>
               </a:rPr>
-              <a:t>The deterministic decay heuristic already shipping in the app classifies every tap even if the CNN is unavailable.</a:t>
+              <a:t>The deterministic decay-time heuristic already shipping in the app classifies every tap even if the trained bundle fails to load, and its raw measurements are always reported alongside.</a:t>
             </a:r>
           </a:p>
         </p:txBody>
@@ -30115,7 +30443,7 @@
                 </a:solidFill>
                 <a:latin typeface="Segoe UI"/>
               </a:rPr>
-              <a:t>Training set: 15 taps from 8 recordings. Grouped leave-one-recording-out accuracy 80% (95% CI 62-96%) against a 53% majority baseline. Small - and we report the cross-validated figure with its interval, never the training score.</a:t>
+              <a:t>Honest training set: 15 own taps on the demo phone, grouped cross-validated accuracy 80% (95% CI 55–93%) -- small and said so out loud. Figure is an illustrative signal model.</a:t>
             </a:r>
           </a:p>
         </p:txBody>
@@ -30154,7 +30482,7 @@
                 </a:solidFill>
                 <a:latin typeface="Segoe UI"/>
               </a:rPr>
-              <a:t>The verdict, its confidence and the model cross-validated accuracy are all printed in the findings log.</a:t>
+              <a:t>Dual stereo speakers play a confirmation tone so a room of judges hears the verdict.</a:t>
             </a:r>
           </a:p>
         </p:txBody>
@@ -30258,7 +30586,7 @@
                 </a:solidFill>
                 <a:latin typeface="Segoe UI"/>
               </a:rPr>
-              <a:t>Every byte stays on the phone: sensors, on-device models, local database, offline PDF.</a:t>
+              <a:t>Every byte stays on the phone: sensors, NPU, on-device LLM, signed PDF.</a:t>
             </a:r>
           </a:p>
         </p:txBody>
@@ -30639,7 +30967,7 @@
                 </a:solidFill>
                 <a:latin typeface="Segoe UI"/>
               </a:rPr>
-              <a:t>Stereo mics · 44.1 kHz PCM · AudioRecord</a:t>
+              <a:t>Stereo mics · 16 kHz PCM · Sensing Hub</a:t>
             </a:r>
           </a:p>
         </p:txBody>
@@ -30717,7 +31045,7 @@
                 </a:solidFill>
                 <a:latin typeface="Segoe UI"/>
               </a:rPr>
-              <a:t>Rotation vector (TYPE_ROTATION_VECTOR)</a:t>
+              <a:t>Rotation vector · ARCore depth</a:t>
             </a:r>
           </a:p>
         </p:txBody>
@@ -30960,7 +31288,7 @@
                 </a:solidFill>
                 <a:latin typeface="Segoe UI"/>
               </a:rPr>
-              <a:t>HOST CPU - MODELS</a:t>
+              <a:t>NPU + GPU (ON-DEVICE AI)</a:t>
             </a:r>
           </a:p>
         </p:txBody>
@@ -30999,7 +31327,7 @@
                 </a:solidFill>
                 <a:latin typeface="Segoe UI"/>
               </a:rPr>
-              <a:t>- YOLOv8n-Seg, 4-class, via PyTorch Lite</a:t>
+              <a:t>• YOLOv8n-Seg INT8 .pte via ExecuTorch, Hexagon HTP, target &lt;30 ms</a:t>
             </a:r>
           </a:p>
           <a:p>
@@ -31015,7 +31343,7 @@
                 </a:solidFill>
                 <a:latin typeface="Segoe UI"/>
               </a:rPr>
-              <a:t>- Tap classifier: 36-feature logistic regression</a:t>
+              <a:t>• Gemma 4 (.litertlm) via LiteRT-LM on the Adreno GPU delegate</a:t>
             </a:r>
           </a:p>
           <a:p>
@@ -31031,7 +31359,7 @@
                 </a:solidFill>
                 <a:latin typeface="Segoe UI"/>
               </a:rPr>
-              <a:t>- ExecuTorch INT8 .pte compiled and in repo; HTP integration not yet in the APK</a:t>
+              <a:t>• Both fall back to CPU under memory/thermal pressure</a:t>
             </a:r>
           </a:p>
         </p:txBody>
@@ -31142,7 +31470,7 @@
                 </a:solidFill>
                 <a:latin typeface="Segoe UI"/>
               </a:rPr>
-              <a:t>HOST CPU - PIPELINE</a:t>
+              <a:t>HOST CPU</a:t>
             </a:r>
           </a:p>
         </p:txBody>
@@ -31181,7 +31509,7 @@
                 </a:solidFill>
                 <a:latin typeface="Segoe UI"/>
               </a:rPr>
-              <a:t>- NMS - mask assembly - area as % of frame</a:t>
+              <a:t>• NMS · mask assembly · area from pinhole model</a:t>
             </a:r>
           </a:p>
           <a:p>
@@ -31197,7 +31525,7 @@
                 </a:solidFill>
                 <a:latin typeface="Segoe UI"/>
               </a:rPr>
-              <a:t>• RMS spike  → 150 ms crop  → log-Mel</a:t>
+              <a:t>• Tap logistic regression, 36 MFCC features, 73 KB</a:t>
             </a:r>
           </a:p>
           <a:p>
@@ -31213,7 +31541,7 @@
                 </a:solidFill>
                 <a:latin typeface="Segoe UI"/>
               </a:rPr>
-              <a:t>- PDF render - SHA-256 of findings - Room DB</a:t>
+              <a:t>• PDF render · SHA-256 · Room DB</a:t>
             </a:r>
           </a:p>
         </p:txBody>
@@ -31379,7 +31707,7 @@
                 </a:solidFill>
                 <a:latin typeface="Segoe UI"/>
               </a:rPr>
-              <a:t>- Replay at 38 kHz (Android has no IR receive path)</a:t>
+              <a:t>• Replay at 38 kHz  → verify via mic</a:t>
             </a:r>
           </a:p>
           <a:p>
@@ -31653,7 +31981,7 @@
                 </a:solidFill>
                 <a:latin typeface="Segoe UI"/>
               </a:rPr>
-              <a:t>OUTPUT   Offline PDF: timestamp + session ID + SHA-256 of the findings on every page, rendered on the phone and shared by Intent or Office Kit. No cloud call at any stage, no INTERNET permission, backups disabled.</a:t>
+              <a:t>OUTPUT  </a:t>
             </a:r>
             <a:r>
               <a:rPr sz="1050" b="0" i="0">
@@ -31662,7 +31990,7 @@
                 </a:solidFill>
                 <a:latin typeface="Segoe UI"/>
               </a:rPr>
-              <a:t/>
+              <a:t>Signed PDF: timestamp + session ID + SHA-256 fingerprint, both parties sign on-screen, shared by Intent or Office Kit. No cloud call at any stage.</a:t>
             </a:r>
           </a:p>
         </p:txBody>
@@ -32546,7 +32874,7 @@
                 </a:solidFill>
                 <a:latin typeface="Segoe UI"/>
               </a:rPr>
-              <a:t>Headroom for the models, not yet used: all three run on the CPU today. The ExecuTorch INT8 lowering is compiled and in the repo.</a:t>
+              <a:t>Runs the segmenter on the NPU and Gemma 4 (LiteRT-LM) on the GPU; tap classifier is a small CPU model</a:t>
             </a:r>
           </a:p>
         </p:txBody>
@@ -32795,7 +33123,7 @@
                 </a:solidFill>
                 <a:latin typeface="Segoe UI"/>
               </a:rPr>
-              <a:t>OIS steadies handheld capture; ultrawide frames a full wall; telephoto reaches a high-ceiling crack. No AR overlay is rendered yet.</a:t>
+              <a:t>OIS steadies the AR baseline overlay; ultrawide captures a full wall; telephoto inspects hairline cracks from 3 m</a:t>
             </a:r>
           </a:p>
         </p:txBody>
@@ -33044,7 +33372,7 @@
                 </a:solidFill>
                 <a:latin typeface="Segoe UI"/>
               </a:rPr>
-              <a:t>Fires an AC, geyser or TV remote code. Android cannot receive IR, so this records that the command was sent, not that the unit responded.</a:t>
+              <a:t>Fires the AC, geyser or TV remote code to prove the appliance works, not just looks fine</a:t>
             </a:r>
           </a:p>
         </p:txBody>
@@ -33127,7 +33455,7 @@
                 </a:solidFill>
                 <a:latin typeface="Segoe UI"/>
               </a:rPr>
-              <a:t>Stereo mics</a:t>
+              <a:t>Stereo mics + Sensing Hub</a:t>
             </a:r>
           </a:p>
         </p:txBody>
@@ -33210,7 +33538,7 @@
                 </a:solidFill>
                 <a:latin typeface="Segoe UI"/>
               </a:rPr>
-              <a:t>Dual mic array, 44.1 kHz PCM capture</a:t>
+              <a:t>Always-on, low-power audio path</a:t>
             </a:r>
           </a:p>
         </p:txBody>
@@ -33293,7 +33621,7 @@
                 </a:solidFill>
                 <a:latin typeface="Segoe UI"/>
               </a:rPr>
-              <a:t>Captures the knuckle-tap transient for the hollow/solid classifier. Not always-on: the Sensing Hub audio path has no third-party API.</a:t>
+              <a:t>Detects the tap transient without waking the main NPU; mic confirms the compressor starts</a:t>
             </a:r>
           </a:p>
         </p:txBody>
@@ -33542,7 +33870,7 @@
                 </a:solidFill>
                 <a:latin typeface="Segoe UI"/>
               </a:rPr>
-              <a:t>Keeps the camera preview and the findings log legible in a sunlit Chennai flat at 2 pm.</a:t>
+              <a:t>AR overlay stays legible in a sunlit Chennai flat at 2 pm</a:t>
             </a:r>
           </a:p>
         </p:txBody>
@@ -33708,7 +34036,7 @@
                 </a:solidFill>
                 <a:latin typeface="Segoe UI"/>
               </a:rPr>
-              <a:t>Sustained load without throttling</a:t>
+              <a:t>Sustained NPU load without throttling</a:t>
             </a:r>
           </a:p>
         </p:txBody>
@@ -33791,7 +34119,7 @@
                 </a:solidFill>
                 <a:latin typeface="Segoe UI"/>
               </a:rPr>
-              <a:t>Twenty-room walkthrough on one charge without the inference slowing down mid-demo.</a:t>
+              <a:t>Twenty-room walkthrough on one charge; inference speed does not degrade mid-demo</a:t>
             </a:r>
           </a:p>
         </p:txBody>

</xml_diff>